<commit_message>
make title slide subtitles bigger on both decks
The subtitles were tiny compared to the main title.  Bumped every
level on the title slide of both the 18-slide and 8-slide decks:

  main title:        44 / 48   ->  54 pt
  subtitle line:     26        ->  34 pt
  progress report:   17 / 18   ->  22-24 pt  (also bolded)
  target venues:     14        ->  19 pt
  repo URL:          13        ->  17 pt

The coral accent bar also extended to span the full text stack
(0.7 in tall to 3.9 in tall) so the layout stays balanced.
</commit_message>
<xml_diff>
--- a/presentation/microgrid_paper_progress.pptx
+++ b/presentation/microgrid_paper_progress.pptx
@@ -3157,8 +3157,8 @@
         </p:nvSpPr>
         <p:spPr>
           <a:xfrm>
-            <a:off x="640080" y="2194560"/>
-            <a:ext cx="137160" cy="2377440"/>
+            <a:off x="640080" y="1554480"/>
+            <a:ext cx="137160" cy="3566160"/>
           </a:xfrm>
           <a:prstGeom prst="rect">
             <a:avLst/>
@@ -3200,8 +3200,8 @@
         </p:nvSpPr>
         <p:spPr>
           <a:xfrm>
-            <a:off x="914400" y="2103120"/>
-            <a:ext cx="10058400" cy="914400"/>
+            <a:off x="914400" y="1554480"/>
+            <a:ext cx="10515600" cy="1097280"/>
           </a:xfrm>
           <a:prstGeom prst="rect">
             <a:avLst/>
@@ -3216,7 +3216,7 @@
           <a:p>
             <a:pPr algn="l"/>
             <a:r>
-              <a:rPr sz="4400" b="1">
+              <a:rPr sz="5400" b="1">
                 <a:solidFill>
                   <a:srgbClr val="FFFFFF"/>
                 </a:solidFill>
@@ -3235,8 +3235,8 @@
         </p:nvSpPr>
         <p:spPr>
           <a:xfrm>
-            <a:off x="914400" y="2926080"/>
-            <a:ext cx="10058400" cy="731520"/>
+            <a:off x="914400" y="2697480"/>
+            <a:ext cx="10515600" cy="822960"/>
           </a:xfrm>
           <a:prstGeom prst="rect">
             <a:avLst/>
@@ -3251,7 +3251,7 @@
           <a:p>
             <a:pPr algn="l"/>
             <a:r>
-              <a:rPr sz="2600" b="0">
+              <a:rPr sz="3400" b="0">
                 <a:solidFill>
                   <a:srgbClr val="2A9D8F"/>
                 </a:solidFill>
@@ -3270,8 +3270,8 @@
         </p:nvSpPr>
         <p:spPr>
           <a:xfrm>
-            <a:off x="914400" y="3749039"/>
-            <a:ext cx="10058400" cy="457200"/>
+            <a:off x="914400" y="3611880"/>
+            <a:ext cx="10515600" cy="640080"/>
           </a:xfrm>
           <a:prstGeom prst="rect">
             <a:avLst/>
@@ -3286,13 +3286,13 @@
           <a:p>
             <a:pPr algn="l"/>
             <a:r>
-              <a:rPr sz="1800" b="0">
+              <a:rPr sz="2200" b="1">
                 <a:solidFill>
                   <a:srgbClr val="E9C46A"/>
                 </a:solidFill>
                 <a:latin typeface="Calibri"/>
               </a:rPr>
-              <a:t>Progress report - CSE side ML pipelines + EEE side simulation</a:t>
+              <a:t>Progress report  -  CSE side ML pipelines  +  EEE side simulation</a:t>
             </a:r>
           </a:p>
         </p:txBody>
@@ -3306,7 +3306,7 @@
         <p:spPr>
           <a:xfrm>
             <a:off x="914400" y="4480560"/>
-            <a:ext cx="10058400" cy="457200"/>
+            <a:ext cx="10515600" cy="548640"/>
           </a:xfrm>
           <a:prstGeom prst="rect">
             <a:avLst/>
@@ -3321,13 +3321,13 @@
           <a:p>
             <a:pPr algn="l"/>
             <a:r>
-              <a:rPr sz="1400" b="0">
+              <a:rPr sz="1900" b="0">
                 <a:solidFill>
                   <a:srgbClr val="F4F1DE"/>
                 </a:solidFill>
                 <a:latin typeface="Calibri"/>
               </a:rPr>
-              <a:t>Target venues: IEEE Trans. Smart Grid (Q1, IF~10)  |  Applied Energy (Q1, IF~11)</a:t>
+              <a:t>Target venues:  IEEE Trans. Smart Grid (Q1, IF~10)  |  Applied Energy (Q1, IF~11)</a:t>
             </a:r>
           </a:p>
         </p:txBody>
@@ -3341,7 +3341,7 @@
         <p:spPr>
           <a:xfrm>
             <a:off x="914400" y="5943600"/>
-            <a:ext cx="10058400" cy="365760"/>
+            <a:ext cx="10515600" cy="457200"/>
           </a:xfrm>
           <a:prstGeom prst="rect">
             <a:avLst/>
@@ -3356,9 +3356,9 @@
           <a:p>
             <a:pPr algn="l"/>
             <a:r>
-              <a:rPr sz="1300" b="0">
-                <a:solidFill>
-                  <a:srgbClr val="606060"/>
+              <a:rPr sz="1700" b="0">
+                <a:solidFill>
+                  <a:srgbClr val="E9C46A"/>
                 </a:solidFill>
                 <a:latin typeface="Consolas"/>
               </a:rPr>

</xml_diff>